<commit_message>
Show slide 5 costs in dollars
</commit_message>
<xml_diff>
--- a/docs/slides/reviewed/Presentation_Group11_Sprint1.pptx
+++ b/docs/slides/reviewed/Presentation_Group11_Sprint1.pptx
@@ -978,7 +978,7 @@
               <a:rPr lang="en-US" dirty="0"/>
               <a:t>SLIDE 5 - Business value (0:30)
 What does that buy? Out of 120 batches, 2 arrive late instead of 41: ninety-five percent fewer than random. That's the course simulator, not a factory. And no batch goes where it can't be made, every decision is on record, and an impossible date is flagged on day one, with options. The price: about a third more than the cheapest rule, which is late nine times in ten.
-Q&amp;A: cost per replay 115,592 for our desk, 111,780 for random, 85,960 for cheapest; ratio to cheapest 1.34 (source cost units, not dollars).</a:t>
+Q&amp;A: cost per replay 115,592 for our desk, 111,780 for random, 85,960 for cheapest; ratio to cheapest 1.34 (shown as $; the data gives cost per piece with no currency, so say so if asked).</a:t>
             </a:r>
             <a:endParaRPr lang="en-US" dirty="0"/>
           </a:p>
@@ -7917,7 +7917,7 @@
                 <a:ea typeface="Arial" pitchFamily="34" charset="-122"/>
                 <a:cs typeface="Arial" pitchFamily="34" charset="-120"/>
               </a:rPr>
-              <a:t>115.6k cost units per run, against 86.0k for always-cheapest (late on 92% of batches) and 111.8k for random.</a:t>
+              <a:t>$115.6k per run, against $86.0k for always-cheapest (late on 92% of batches) and $111.8k for random.</a:t>
             </a:r>
             <a:endParaRPr lang="en-US" sz="1050" dirty="0"/>
           </a:p>

</xml_diff>